<commit_message>
Put the mockup, architecture diagram, and ERD in the README and deck.
Replace the GitHub mermaid architecture widget with a light PNG of the same flowchart, add the requested ER diagram (image plus mermaid source), and embed the hi-fi mockup frames in both the README and the Demo Day .pptx.

Co-authored-by: Issercio <Issercio@users.noreply.github.com>
</commit_message>
<xml_diff>
--- a/docs/presentation/Pivoine-Lilas.pptx
+++ b/docs/presentation/Pivoine-Lilas.pptx
@@ -27,6 +27,8 @@
     <p:sldId id="275" r:id="rId26"/>
     <p:sldId id="276" r:id="rId27"/>
     <p:sldId id="277" r:id="rId28"/>
+    <p:sldId id="278" r:id="rId29"/>
+    <p:sldId id="279" r:id="rId30"/>
   </p:sldIdLst>
   <p:sldSz cx="12191695" cy="6858000" type="screen4x3"/>
   <p:notesSz cx="6858000" cy="9144000"/>
@@ -3621,533 +3623,30 @@
           </a:p>
         </p:txBody>
       </p:sp>
-      <p:sp>
-        <p:nvSpPr>
-          <p:cNvPr id="8" name="Rounded Rectangle 7"/>
-          <p:cNvSpPr/>
-          <p:nvPr/>
-        </p:nvSpPr>
-        <p:spPr>
-          <a:xfrm>
-            <a:off x="365760" y="1143000"/>
-            <a:ext cx="2743200" cy="2286000"/>
-          </a:xfrm>
-          <a:prstGeom prst="roundRect">
-            <a:avLst/>
-          </a:prstGeom>
-          <a:solidFill>
-            <a:srgbClr val="FFFFFF"/>
-          </a:solidFill>
-          <a:ln>
-            <a:solidFill>
-              <a:srgbClr val="BC6288"/>
-            </a:solidFill>
-          </a:ln>
-        </p:spPr>
-        <p:style>
-          <a:lnRef idx="1">
-            <a:schemeClr val="accent1"/>
-          </a:lnRef>
-          <a:fillRef idx="3">
-            <a:schemeClr val="accent1"/>
-          </a:fillRef>
-          <a:effectRef idx="2">
-            <a:schemeClr val="accent1"/>
-          </a:effectRef>
-          <a:fontRef idx="minor">
-            <a:schemeClr val="lt1"/>
-          </a:fontRef>
-        </p:style>
-        <p:txBody>
-          <a:bodyPr rtlCol="0" anchor="ctr"/>
-          <a:lstStyle/>
-          <a:p>
-            <a:pPr algn="ctr"/>
-          </a:p>
-        </p:txBody>
-      </p:sp>
-      <p:sp>
-        <p:nvSpPr>
-          <p:cNvPr id="9" name="TextBox 8"/>
-          <p:cNvSpPr txBox="1"/>
-          <p:nvPr/>
-        </p:nvSpPr>
-        <p:spPr>
-          <a:xfrm>
-            <a:off x="475488" y="1216152"/>
-            <a:ext cx="2560320" cy="2176272"/>
-          </a:xfrm>
-          <a:prstGeom prst="rect">
-            <a:avLst/>
-          </a:prstGeom>
-          <a:noFill/>
-        </p:spPr>
-        <p:txBody>
-          <a:bodyPr wrap="square">
-            <a:spAutoFit/>
-          </a:bodyPr>
-          <a:lstStyle/>
-          <a:p>
-            <a:r>
-              <a:rPr b="1" sz="1400">
-                <a:solidFill>
-                  <a:srgbClr val="BC6288"/>
-                </a:solidFill>
-                <a:latin typeface="Calibri"/>
-              </a:rPr>
-              <a:t>1. Browser</a:t>
-            </a:r>
-          </a:p>
-          <a:p>
-            <a:pPr>
-              <a:defRPr sz="1200">
-                <a:solidFill>
-                  <a:srgbClr val="3A2A30"/>
-                </a:solidFill>
-                <a:latin typeface="Calibri"/>
-              </a:defRPr>
-            </a:pPr>
-            <a:r>
-              <a:t>Jinja pages</a:t>
-            </a:r>
-          </a:p>
-          <a:p>
-            <a:pPr>
-              <a:defRPr sz="1200">
-                <a:solidFill>
-                  <a:srgbClr val="3A2A30"/>
-                </a:solidFill>
-                <a:latin typeface="Calibri"/>
-              </a:defRPr>
-            </a:pPr>
-            <a:r>
-              <a:t>api.js / FloraCart</a:t>
-            </a:r>
-          </a:p>
-          <a:p>
-            <a:pPr>
-              <a:defRPr sz="1200">
-                <a:solidFill>
-                  <a:srgbClr val="3A2A30"/>
-                </a:solidFill>
-                <a:latin typeface="Calibri"/>
-              </a:defRPr>
-            </a:pPr>
-            <a:r>
-              <a:t>Bearer JSON</a:t>
-            </a:r>
-          </a:p>
-        </p:txBody>
-      </p:sp>
-      <p:sp>
-        <p:nvSpPr>
-          <p:cNvPr id="10" name="Rounded Rectangle 9"/>
-          <p:cNvSpPr/>
-          <p:nvPr/>
-        </p:nvSpPr>
-        <p:spPr>
-          <a:xfrm>
-            <a:off x="3246120" y="1143000"/>
-            <a:ext cx="2743200" cy="2286000"/>
-          </a:xfrm>
-          <a:prstGeom prst="roundRect">
-            <a:avLst/>
-          </a:prstGeom>
-          <a:solidFill>
-            <a:srgbClr val="FFFFFF"/>
-          </a:solidFill>
-          <a:ln>
-            <a:solidFill>
-              <a:srgbClr val="BC6288"/>
-            </a:solidFill>
-          </a:ln>
-        </p:spPr>
-        <p:style>
-          <a:lnRef idx="1">
-            <a:schemeClr val="accent1"/>
-          </a:lnRef>
-          <a:fillRef idx="3">
-            <a:schemeClr val="accent1"/>
-          </a:fillRef>
-          <a:effectRef idx="2">
-            <a:schemeClr val="accent1"/>
-          </a:effectRef>
-          <a:fontRef idx="minor">
-            <a:schemeClr val="lt1"/>
-          </a:fontRef>
-        </p:style>
-        <p:txBody>
-          <a:bodyPr rtlCol="0" anchor="ctr"/>
-          <a:lstStyle/>
-          <a:p>
-            <a:pPr algn="ctr"/>
-          </a:p>
-        </p:txBody>
-      </p:sp>
-      <p:sp>
-        <p:nvSpPr>
-          <p:cNvPr id="11" name="TextBox 10"/>
-          <p:cNvSpPr txBox="1"/>
-          <p:nvPr/>
-        </p:nvSpPr>
-        <p:spPr>
-          <a:xfrm>
-            <a:off x="3355848" y="1216152"/>
-            <a:ext cx="2560320" cy="2176272"/>
-          </a:xfrm>
-          <a:prstGeom prst="rect">
-            <a:avLst/>
-          </a:prstGeom>
-          <a:noFill/>
-        </p:spPr>
-        <p:txBody>
-          <a:bodyPr wrap="square">
-            <a:spAutoFit/>
-          </a:bodyPr>
-          <a:lstStyle/>
-          <a:p>
-            <a:r>
-              <a:rPr b="1" sz="1400">
-                <a:solidFill>
-                  <a:srgbClr val="BC6288"/>
-                </a:solidFill>
-                <a:latin typeface="Calibri"/>
-              </a:rPr>
-              <a:t>2. Flask</a:t>
-            </a:r>
-          </a:p>
-          <a:p>
-            <a:pPr>
-              <a:defRPr sz="1200">
-                <a:solidFill>
-                  <a:srgbClr val="3A2A30"/>
-                </a:solidFill>
-                <a:latin typeface="Calibri"/>
-              </a:defRPr>
-            </a:pPr>
-            <a:r>
-              <a:t>REST /api/v1</a:t>
-            </a:r>
-          </a:p>
-          <a:p>
-            <a:pPr>
-              <a:defRPr sz="1200">
-                <a:solidFill>
-                  <a:srgbClr val="3A2A30"/>
-                </a:solidFill>
-                <a:latin typeface="Calibri"/>
-              </a:defRPr>
-            </a:pPr>
-            <a:r>
-              <a:t>checkout_service</a:t>
-            </a:r>
-          </a:p>
-          <a:p>
-            <a:pPr>
-              <a:defRPr sz="1200">
-                <a:solidFill>
-                  <a:srgbClr val="3A2A30"/>
-                </a:solidFill>
-                <a:latin typeface="Calibri"/>
-              </a:defRPr>
-            </a:pPr>
-            <a:r>
-              <a:t>JWT + DB is_admin</a:t>
-            </a:r>
-          </a:p>
-        </p:txBody>
-      </p:sp>
-      <p:sp>
-        <p:nvSpPr>
-          <p:cNvPr id="12" name="Rounded Rectangle 11"/>
-          <p:cNvSpPr/>
-          <p:nvPr/>
-        </p:nvSpPr>
-        <p:spPr>
-          <a:xfrm>
-            <a:off x="6126480" y="1143000"/>
-            <a:ext cx="2743200" cy="2286000"/>
-          </a:xfrm>
-          <a:prstGeom prst="roundRect">
-            <a:avLst/>
-          </a:prstGeom>
-          <a:solidFill>
-            <a:srgbClr val="FFFFFF"/>
-          </a:solidFill>
-          <a:ln>
-            <a:solidFill>
-              <a:srgbClr val="BC6288"/>
-            </a:solidFill>
-          </a:ln>
-        </p:spPr>
-        <p:style>
-          <a:lnRef idx="1">
-            <a:schemeClr val="accent1"/>
-          </a:lnRef>
-          <a:fillRef idx="3">
-            <a:schemeClr val="accent1"/>
-          </a:fillRef>
-          <a:effectRef idx="2">
-            <a:schemeClr val="accent1"/>
-          </a:effectRef>
-          <a:fontRef idx="minor">
-            <a:schemeClr val="lt1"/>
-          </a:fontRef>
-        </p:style>
-        <p:txBody>
-          <a:bodyPr rtlCol="0" anchor="ctr"/>
-          <a:lstStyle/>
-          <a:p>
-            <a:pPr algn="ctr"/>
-          </a:p>
-        </p:txBody>
-      </p:sp>
-      <p:sp>
-        <p:nvSpPr>
-          <p:cNvPr id="13" name="TextBox 12"/>
-          <p:cNvSpPr txBox="1"/>
-          <p:nvPr/>
-        </p:nvSpPr>
-        <p:spPr>
-          <a:xfrm>
-            <a:off x="6236208" y="1216152"/>
-            <a:ext cx="2560320" cy="2176272"/>
-          </a:xfrm>
-          <a:prstGeom prst="rect">
-            <a:avLst/>
-          </a:prstGeom>
-          <a:noFill/>
-        </p:spPr>
-        <p:txBody>
-          <a:bodyPr wrap="square">
-            <a:spAutoFit/>
-          </a:bodyPr>
-          <a:lstStyle/>
-          <a:p>
-            <a:r>
-              <a:rPr b="1" sz="1400">
-                <a:solidFill>
-                  <a:srgbClr val="BC6288"/>
-                </a:solidFill>
-                <a:latin typeface="Calibri"/>
-              </a:rPr>
-              <a:t>3. Data</a:t>
-            </a:r>
-          </a:p>
-          <a:p>
-            <a:pPr>
-              <a:defRPr sz="1200">
-                <a:solidFill>
-                  <a:srgbClr val="3A2A30"/>
-                </a:solidFill>
-                <a:latin typeface="Calibri"/>
-              </a:defRPr>
-            </a:pPr>
-            <a:r>
-              <a:t>SQLite / Postgres</a:t>
-            </a:r>
-          </a:p>
-          <a:p>
-            <a:pPr>
-              <a:defRPr sz="1200">
-                <a:solidFill>
-                  <a:srgbClr val="3A2A30"/>
-                </a:solidFill>
-                <a:latin typeface="Calibri"/>
-              </a:defRPr>
-            </a:pPr>
-            <a:r>
-              <a:t>Numeric(10,2)</a:t>
-            </a:r>
-          </a:p>
-          <a:p>
-            <a:pPr>
-              <a:defRPr sz="1200">
-                <a:solidFill>
-                  <a:srgbClr val="3A2A30"/>
-                </a:solidFill>
-                <a:latin typeface="Calibri"/>
-              </a:defRPr>
-            </a:pPr>
-            <a:r>
-              <a:t>static photos</a:t>
-            </a:r>
-          </a:p>
-        </p:txBody>
-      </p:sp>
-      <p:sp>
-        <p:nvSpPr>
-          <p:cNvPr id="14" name="Rounded Rectangle 13"/>
-          <p:cNvSpPr/>
-          <p:nvPr/>
-        </p:nvSpPr>
-        <p:spPr>
-          <a:xfrm>
-            <a:off x="9006840" y="1143000"/>
-            <a:ext cx="2743200" cy="2286000"/>
-          </a:xfrm>
-          <a:prstGeom prst="roundRect">
-            <a:avLst/>
-          </a:prstGeom>
-          <a:solidFill>
-            <a:srgbClr val="FFFFFF"/>
-          </a:solidFill>
-          <a:ln>
-            <a:solidFill>
-              <a:srgbClr val="BC6288"/>
-            </a:solidFill>
-          </a:ln>
-        </p:spPr>
-        <p:style>
-          <a:lnRef idx="1">
-            <a:schemeClr val="accent1"/>
-          </a:lnRef>
-          <a:fillRef idx="3">
-            <a:schemeClr val="accent1"/>
-          </a:fillRef>
-          <a:effectRef idx="2">
-            <a:schemeClr val="accent1"/>
-          </a:effectRef>
-          <a:fontRef idx="minor">
-            <a:schemeClr val="lt1"/>
-          </a:fontRef>
-        </p:style>
-        <p:txBody>
-          <a:bodyPr rtlCol="0" anchor="ctr"/>
-          <a:lstStyle/>
-          <a:p>
-            <a:pPr algn="ctr"/>
-          </a:p>
-        </p:txBody>
-      </p:sp>
-      <p:sp>
-        <p:nvSpPr>
-          <p:cNvPr id="15" name="TextBox 14"/>
-          <p:cNvSpPr txBox="1"/>
-          <p:nvPr/>
-        </p:nvSpPr>
-        <p:spPr>
-          <a:xfrm>
-            <a:off x="9116567" y="1216152"/>
-            <a:ext cx="2560320" cy="2176272"/>
-          </a:xfrm>
-          <a:prstGeom prst="rect">
-            <a:avLst/>
-          </a:prstGeom>
-          <a:noFill/>
-        </p:spPr>
-        <p:txBody>
-          <a:bodyPr wrap="square">
-            <a:spAutoFit/>
-          </a:bodyPr>
-          <a:lstStyle/>
-          <a:p>
-            <a:r>
-              <a:rPr b="1" sz="1400">
-                <a:solidFill>
-                  <a:srgbClr val="BC6288"/>
-                </a:solidFill>
-                <a:latin typeface="Calibri"/>
-              </a:rPr>
-              <a:t>4. Pay</a:t>
-            </a:r>
-          </a:p>
-          <a:p>
-            <a:pPr>
-              <a:defRPr sz="1200">
-                <a:solidFill>
-                  <a:srgbClr val="3A2A30"/>
-                </a:solidFill>
-                <a:latin typeface="Calibri"/>
-              </a:defRPr>
-            </a:pPr>
-            <a:r>
-              <a:t>Test cards</a:t>
-            </a:r>
-          </a:p>
-          <a:p>
-            <a:pPr>
-              <a:defRPr sz="1200">
-                <a:solidFill>
-                  <a:srgbClr val="3A2A30"/>
-                </a:solidFill>
-                <a:latin typeface="Calibri"/>
-              </a:defRPr>
-            </a:pPr>
-            <a:r>
-              <a:t>or Stripe HTTPS</a:t>
-            </a:r>
-          </a:p>
-          <a:p>
-            <a:pPr>
-              <a:defRPr sz="1200">
-                <a:solidFill>
-                  <a:srgbClr val="3A2A30"/>
-                </a:solidFill>
-                <a:latin typeface="Calibri"/>
-              </a:defRPr>
-            </a:pPr>
-            <a:r>
-              <a:t>orders paid/deposit</a:t>
-            </a:r>
-          </a:p>
-        </p:txBody>
-      </p:sp>
-      <p:sp>
-        <p:nvSpPr>
-          <p:cNvPr id="16" name="TextBox 15"/>
-          <p:cNvSpPr txBox="1"/>
-          <p:nvPr/>
-        </p:nvSpPr>
-        <p:spPr>
-          <a:xfrm>
-            <a:off x="411480" y="3657600"/>
-            <a:ext cx="11338560" cy="5029200"/>
-          </a:xfrm>
-          <a:prstGeom prst="rect">
-            <a:avLst/>
-          </a:prstGeom>
-          <a:noFill/>
-        </p:spPr>
-        <p:txBody>
-          <a:bodyPr wrap="square">
-            <a:spAutoFit/>
-          </a:bodyPr>
-          <a:lstStyle/>
-          <a:p>
-            <a:pPr>
-              <a:spcAft>
-                <a:spcPts val="800"/>
-              </a:spcAft>
-              <a:defRPr sz="1600">
-                <a:solidFill>
-                  <a:srgbClr val="3A2A30"/>
-                </a:solidFill>
-                <a:latin typeface="Calibri"/>
-              </a:defRPr>
-            </a:pPr>
-            <a:r>
-              <a:t>Flow: HTTPS/HTTP JSON → Flask → SQL. Optional Stripe api.stripe.com. Backup = florashop.db or managed PostgreSQL.</a:t>
-            </a:r>
-          </a:p>
-          <a:p>
-            <a:pPr>
-              <a:spcAft>
-                <a:spcPts val="800"/>
-              </a:spcAft>
-              <a:defRPr sz="1600">
-                <a:solidFill>
-                  <a:srgbClr val="3A2A30"/>
-                </a:solidFill>
-                <a:latin typeface="Calibri"/>
-              </a:defRPr>
-            </a:pPr>
-            <a:r>
-              <a:t>POST /payments/checkout never uses a client price. payment_intent_id is refused here (owner JWT → /confirm-payment).</a:t>
-            </a:r>
-          </a:p>
-        </p:txBody>
-      </p:sp>
+      <p:pic>
+        <p:nvPicPr>
+          <p:cNvPr id="8" name="Picture 7" descr="architecture.png"/>
+          <p:cNvPicPr>
+            <a:picLocks noChangeAspect="1"/>
+          </p:cNvPicPr>
+          <p:nvPr/>
+        </p:nvPicPr>
+        <p:blipFill>
+          <a:blip r:embed="rId2"/>
+          <a:stretch>
+            <a:fillRect/>
+          </a:stretch>
+        </p:blipFill>
+        <p:spPr>
+          <a:xfrm>
+            <a:off x="411480" y="1051560"/>
+            <a:ext cx="11338560" cy="5349240"/>
+          </a:xfrm>
+          <a:prstGeom prst="rect">
+            <a:avLst/>
+          </a:prstGeom>
+        </p:spPr>
+      </p:pic>
     </p:spTree>
   </p:cSld>
   <p:clrMapOvr>
@@ -4397,441 +3896,30 @@
           </a:p>
         </p:txBody>
       </p:sp>
-      <p:graphicFrame>
-        <p:nvGraphicFramePr>
-          <p:cNvPr id="8" name="Table 7"/>
-          <p:cNvGraphicFramePr>
-            <a:graphicFrameLocks noGrp="1"/>
-          </p:cNvGraphicFramePr>
-          <p:nvPr/>
-        </p:nvGraphicFramePr>
-        <p:xfrm>
-          <a:off x="365760" y="1097280"/>
-          <a:ext cx="11430000" cy="4206240"/>
-        </p:xfrm>
-        <a:graphic>
-          <a:graphicData uri="http://schemas.openxmlformats.org/drawingml/2006/table">
-            <a:tbl>
-              <a:tblPr firstRow="1" bandRow="1">
-                <a:tableStyleId>{5C22544A-7EE6-4342-B048-85BDC9FD1C3A}</a:tableStyleId>
-              </a:tblPr>
-              <a:tblGrid>
-                <a:gridCol w="3810000"/>
-                <a:gridCol w="3810000"/>
-                <a:gridCol w="3810000"/>
-              </a:tblGrid>
-              <a:tr h="701040">
-                <a:tc>
-                  <a:txBody>
-                    <a:bodyPr/>
-                    <a:lstStyle/>
-                    <a:p>
-                      <a:pPr>
-                        <a:defRPr b="1" sz="1100">
-                          <a:solidFill>
-                            <a:srgbClr val="FFFFFF"/>
-                          </a:solidFill>
-                          <a:latin typeface="Calibri"/>
-                        </a:defRPr>
-                      </a:pPr>
-                      <a:r>
-                        <a:t>Table</a:t>
-                      </a:r>
-                    </a:p>
-                  </a:txBody>
-                  <a:tcPr>
-                    <a:solidFill>
-                      <a:srgbClr val="BC6288"/>
-                    </a:solidFill>
-                  </a:tcPr>
-                </a:tc>
-                <a:tc>
-                  <a:txBody>
-                    <a:bodyPr/>
-                    <a:lstStyle/>
-                    <a:p>
-                      <a:pPr>
-                        <a:defRPr b="1" sz="1100">
-                          <a:solidFill>
-                            <a:srgbClr val="FFFFFF"/>
-                          </a:solidFill>
-                          <a:latin typeface="Calibri"/>
-                        </a:defRPr>
-                      </a:pPr>
-                      <a:r>
-                        <a:t>PK / FK</a:t>
-                      </a:r>
-                    </a:p>
-                  </a:txBody>
-                  <a:tcPr>
-                    <a:solidFill>
-                      <a:srgbClr val="BC6288"/>
-                    </a:solidFill>
-                  </a:tcPr>
-                </a:tc>
-                <a:tc>
-                  <a:txBody>
-                    <a:bodyPr/>
-                    <a:lstStyle/>
-                    <a:p>
-                      <a:pPr>
-                        <a:defRPr b="1" sz="1100">
-                          <a:solidFill>
-                            <a:srgbClr val="FFFFFF"/>
-                          </a:solidFill>
-                          <a:latin typeface="Calibri"/>
-                        </a:defRPr>
-                      </a:pPr>
-                      <a:r>
-                        <a:t>Rule</a:t>
-                      </a:r>
-                    </a:p>
-                  </a:txBody>
-                  <a:tcPr>
-                    <a:solidFill>
-                      <a:srgbClr val="BC6288"/>
-                    </a:solidFill>
-                  </a:tcPr>
-                </a:tc>
-              </a:tr>
-              <a:tr h="701040">
-                <a:tc>
-                  <a:txBody>
-                    <a:bodyPr/>
-                    <a:lstStyle/>
-                    <a:p>
-                      <a:pPr>
-                        <a:defRPr sz="1100">
-                          <a:solidFill>
-                            <a:srgbClr val="3A2A30"/>
-                          </a:solidFill>
-                          <a:latin typeface="Calibri"/>
-                        </a:defRPr>
-                      </a:pPr>
-                      <a:r>
-                        <a:t>users</a:t>
-                      </a:r>
-                    </a:p>
-                  </a:txBody>
-                  <a:tcPr/>
-                </a:tc>
-                <a:tc>
-                  <a:txBody>
-                    <a:bodyPr/>
-                    <a:lstStyle/>
-                    <a:p>
-                      <a:pPr>
-                        <a:defRPr sz="1100">
-                          <a:solidFill>
-                            <a:srgbClr val="3A2A30"/>
-                          </a:solidFill>
-                          <a:latin typeface="Calibri"/>
-                        </a:defRPr>
-                      </a:pPr>
-                      <a:r>
-                        <a:t>id · email unique</a:t>
-                      </a:r>
-                    </a:p>
-                  </a:txBody>
-                  <a:tcPr/>
-                </a:tc>
-                <a:tc>
-                  <a:txBody>
-                    <a:bodyPr/>
-                    <a:lstStyle/>
-                    <a:p>
-                      <a:pPr>
-                        <a:defRPr sz="1100">
-                          <a:solidFill>
-                            <a:srgbClr val="3A2A30"/>
-                          </a:solidFill>
-                          <a:latin typeface="Calibri"/>
-                        </a:defRPr>
-                      </a:pPr>
-                      <a:r>
-                        <a:t>hash only · is_admin default false</a:t>
-                      </a:r>
-                    </a:p>
-                  </a:txBody>
-                  <a:tcPr/>
-                </a:tc>
-              </a:tr>
-              <a:tr h="701040">
-                <a:tc>
-                  <a:txBody>
-                    <a:bodyPr/>
-                    <a:lstStyle/>
-                    <a:p>
-                      <a:pPr>
-                        <a:defRPr sz="1100">
-                          <a:solidFill>
-                            <a:srgbClr val="3A2A30"/>
-                          </a:solidFill>
-                          <a:latin typeface="Calibri"/>
-                        </a:defRPr>
-                      </a:pPr>
-                      <a:r>
-                        <a:t>categories → products</a:t>
-                      </a:r>
-                    </a:p>
-                  </a:txBody>
-                  <a:tcPr>
-                    <a:solidFill>
-                      <a:srgbClr val="F8F5F2"/>
-                    </a:solidFill>
-                  </a:tcPr>
-                </a:tc>
-                <a:tc>
-                  <a:txBody>
-                    <a:bodyPr/>
-                    <a:lstStyle/>
-                    <a:p>
-                      <a:pPr>
-                        <a:defRPr sz="1100">
-                          <a:solidFill>
-                            <a:srgbClr val="3A2A30"/>
-                          </a:solidFill>
-                          <a:latin typeface="Calibri"/>
-                        </a:defRPr>
-                      </a:pPr>
-                      <a:r>
-                        <a:t>category_id</a:t>
-                      </a:r>
-                    </a:p>
-                  </a:txBody>
-                  <a:tcPr>
-                    <a:solidFill>
-                      <a:srgbClr val="F8F5F2"/>
-                    </a:solidFill>
-                  </a:tcPr>
-                </a:tc>
-                <a:tc>
-                  <a:txBody>
-                    <a:bodyPr/>
-                    <a:lstStyle/>
-                    <a:p>
-                      <a:pPr>
-                        <a:defRPr sz="1100">
-                          <a:solidFill>
-                            <a:srgbClr val="3A2A30"/>
-                          </a:solidFill>
-                          <a:latin typeface="Calibri"/>
-                        </a:defRPr>
-                      </a:pPr>
-                      <a:r>
-                        <a:t>price Numeric · color #rrggbb · image path</a:t>
-                      </a:r>
-                    </a:p>
-                  </a:txBody>
-                  <a:tcPr>
-                    <a:solidFill>
-                      <a:srgbClr val="F8F5F2"/>
-                    </a:solidFill>
-                  </a:tcPr>
-                </a:tc>
-              </a:tr>
-              <a:tr h="701040">
-                <a:tc>
-                  <a:txBody>
-                    <a:bodyPr/>
-                    <a:lstStyle/>
-                    <a:p>
-                      <a:pPr>
-                        <a:defRPr sz="1100">
-                          <a:solidFill>
-                            <a:srgbClr val="3A2A30"/>
-                          </a:solidFill>
-                          <a:latin typeface="Calibri"/>
-                        </a:defRPr>
-                      </a:pPr>
-                      <a:r>
-                        <a:t>orders → order_items</a:t>
-                      </a:r>
-                    </a:p>
-                  </a:txBody>
-                  <a:tcPr/>
-                </a:tc>
-                <a:tc>
-                  <a:txBody>
-                    <a:bodyPr/>
-                    <a:lstStyle/>
-                    <a:p>
-                      <a:pPr>
-                        <a:defRPr sz="1100">
-                          <a:solidFill>
-                            <a:srgbClr val="3A2A30"/>
-                          </a:solidFill>
-                          <a:latin typeface="Calibri"/>
-                        </a:defRPr>
-                      </a:pPr>
-                      <a:r>
-                        <a:t>user_id nullable</a:t>
-                      </a:r>
-                    </a:p>
-                  </a:txBody>
-                  <a:tcPr/>
-                </a:tc>
-                <a:tc>
-                  <a:txBody>
-                    <a:bodyPr/>
-                    <a:lstStyle/>
-                    <a:p>
-                      <a:pPr>
-                        <a:defRPr sz="1100">
-                          <a:solidFill>
-                            <a:srgbClr val="3A2A30"/>
-                          </a:solidFill>
-                          <a:latin typeface="Calibri"/>
-                        </a:defRPr>
-                      </a:pPr>
-                      <a:r>
-                        <a:t>deposit, status, prep, card_last4, no PAN</a:t>
-                      </a:r>
-                    </a:p>
-                  </a:txBody>
-                  <a:tcPr/>
-                </a:tc>
-              </a:tr>
-              <a:tr h="701040">
-                <a:tc>
-                  <a:txBody>
-                    <a:bodyPr/>
-                    <a:lstStyle/>
-                    <a:p>
-                      <a:pPr>
-                        <a:defRPr sz="1100">
-                          <a:solidFill>
-                            <a:srgbClr val="3A2A30"/>
-                          </a:solidFill>
-                          <a:latin typeface="Calibri"/>
-                        </a:defRPr>
-                      </a:pPr>
-                      <a:r>
-                        <a:t>shop_themes ↔ products</a:t>
-                      </a:r>
-                    </a:p>
-                  </a:txBody>
-                  <a:tcPr>
-                    <a:solidFill>
-                      <a:srgbClr val="F8F5F2"/>
-                    </a:solidFill>
-                  </a:tcPr>
-                </a:tc>
-                <a:tc>
-                  <a:txBody>
-                    <a:bodyPr/>
-                    <a:lstStyle/>
-                    <a:p>
-                      <a:pPr>
-                        <a:defRPr sz="1100">
-                          <a:solidFill>
-                            <a:srgbClr val="3A2A30"/>
-                          </a:solidFill>
-                          <a:latin typeface="Calibri"/>
-                        </a:defRPr>
-                      </a:pPr>
-                      <a:r>
-                        <a:t>theme_products</a:t>
-                      </a:r>
-                    </a:p>
-                  </a:txBody>
-                  <a:tcPr>
-                    <a:solidFill>
-                      <a:srgbClr val="F8F5F2"/>
-                    </a:solidFill>
-                  </a:tcPr>
-                </a:tc>
-                <a:tc>
-                  <a:txBody>
-                    <a:bodyPr/>
-                    <a:lstStyle/>
-                    <a:p>
-                      <a:pPr>
-                        <a:defRPr sz="1100">
-                          <a:solidFill>
-                            <a:srgbClr val="3A2A30"/>
-                          </a:solidFill>
-                          <a:latin typeface="Calibri"/>
-                        </a:defRPr>
-                      </a:pPr>
-                      <a:r>
-                        <a:t>vitrine one row season_id + theme_id</a:t>
-                      </a:r>
-                    </a:p>
-                  </a:txBody>
-                  <a:tcPr>
-                    <a:solidFill>
-                      <a:srgbClr val="F8F5F2"/>
-                    </a:solidFill>
-                  </a:tcPr>
-                </a:tc>
-              </a:tr>
-              <a:tr h="701040">
-                <a:tc>
-                  <a:txBody>
-                    <a:bodyPr/>
-                    <a:lstStyle/>
-                    <a:p>
-                      <a:pPr>
-                        <a:defRPr sz="1100">
-                          <a:solidFill>
-                            <a:srgbClr val="3A2A30"/>
-                          </a:solidFill>
-                          <a:latin typeface="Calibri"/>
-                        </a:defRPr>
-                      </a:pPr>
-                      <a:r>
-                        <a:t>reviews*, prices*</a:t>
-                      </a:r>
-                    </a:p>
-                  </a:txBody>
-                  <a:tcPr/>
-                </a:tc>
-                <a:tc>
-                  <a:txBody>
-                    <a:bodyPr/>
-                    <a:lstStyle/>
-                    <a:p>
-                      <a:pPr>
-                        <a:defRPr sz="1100">
-                          <a:solidFill>
-                            <a:srgbClr val="3A2A30"/>
-                          </a:solidFill>
-                          <a:latin typeface="Calibri"/>
-                        </a:defRPr>
-                      </a:pPr>
-                      <a:r>
-                        <a:t>leftovers</a:t>
-                      </a:r>
-                    </a:p>
-                  </a:txBody>
-                  <a:tcPr/>
-                </a:tc>
-                <a:tc>
-                  <a:txBody>
-                    <a:bodyPr/>
-                    <a:lstStyle/>
-                    <a:p>
-                      <a:pPr>
-                        <a:defRPr sz="1100">
-                          <a:solidFill>
-                            <a:srgbClr val="3A2A30"/>
-                          </a:solidFill>
-                          <a:latin typeface="Calibri"/>
-                        </a:defRPr>
-                      </a:pPr>
-                      <a:r>
-                        <a:t>not on the purchase path</a:t>
-                      </a:r>
-                    </a:p>
-                  </a:txBody>
-                  <a:tcPr/>
-                </a:tc>
-              </a:tr>
-            </a:tbl>
-          </a:graphicData>
-        </a:graphic>
-      </p:graphicFrame>
+      <p:pic>
+        <p:nvPicPr>
+          <p:cNvPr id="8" name="Picture 7" descr="erd.png"/>
+          <p:cNvPicPr>
+            <a:picLocks noChangeAspect="1"/>
+          </p:cNvPicPr>
+          <p:nvPr/>
+        </p:nvPicPr>
+        <p:blipFill>
+          <a:blip r:embed="rId2"/>
+          <a:stretch>
+            <a:fillRect/>
+          </a:stretch>
+        </p:blipFill>
+        <p:spPr>
+          <a:xfrm>
+            <a:off x="3566160" y="1005840"/>
+            <a:ext cx="5029200" cy="5440680"/>
+          </a:xfrm>
+          <a:prstGeom prst="rect">
+            <a:avLst/>
+          </a:prstGeom>
+        </p:spPr>
+      </p:pic>
     </p:spTree>
   </p:cSld>
   <p:clrMapOvr>
@@ -9494,7 +8582,7 @@
                 </a:solidFill>
                 <a:latin typeface="Calibri"/>
               </a:rPr>
-              <a:t>MOCKUPS = THE LIVE UI</a:t>
+              <a:t>MAQUETTE</a:t>
             </a:r>
           </a:p>
         </p:txBody>
@@ -9528,14 +8616,14 @@
                 </a:solidFill>
                 <a:latin typeface="Calibri"/>
               </a:rPr>
-              <a:t>Same palette, real data</a:t>
+              <a:t>Desktop — palette, accueil, shop, paiement</a:t>
             </a:r>
           </a:p>
         </p:txBody>
       </p:sp>
       <p:pic>
         <p:nvPicPr>
-          <p:cNvPr id="8" name="Picture 7" descr="accueil.png"/>
+          <p:cNvPr id="8" name="Picture 7" descr="mockup-palette.png"/>
           <p:cNvPicPr>
             <a:picLocks noChangeAspect="1"/>
           </p:cNvPicPr>
@@ -9549,8 +8637,8 @@
         </p:blipFill>
         <p:spPr>
           <a:xfrm>
-            <a:off x="365760" y="1143000"/>
-            <a:ext cx="2697480" cy="4023360"/>
+            <a:off x="320040" y="1097280"/>
+            <a:ext cx="2743200" cy="3977639"/>
           </a:xfrm>
           <a:prstGeom prst="rect">
             <a:avLst/>
@@ -9565,8 +8653,8 @@
         </p:nvSpPr>
         <p:spPr>
           <a:xfrm>
-            <a:off x="365760" y="5212080"/>
-            <a:ext cx="2697480" cy="320040"/>
+            <a:off x="320040" y="5120640"/>
+            <a:ext cx="2743200" cy="292608"/>
           </a:xfrm>
           <a:prstGeom prst="rect">
             <a:avLst/>
@@ -9585,15 +8673,16 @@
                 <a:solidFill>
                   <a:srgbClr val="BC6288"/>
                 </a:solidFill>
+                <a:latin typeface="Calibri"/>
               </a:rPr>
-              <a:t>Home</a:t>
+              <a:t>Système visuel</a:t>
             </a:r>
           </a:p>
         </p:txBody>
       </p:sp>
       <p:pic>
         <p:nvPicPr>
-          <p:cNvPr id="10" name="Picture 9" descr="shop.jpg"/>
+          <p:cNvPr id="10" name="Picture 9" descr="mockup-accueil.png"/>
           <p:cNvPicPr>
             <a:picLocks noChangeAspect="1"/>
           </p:cNvPicPr>
@@ -9607,8 +8696,8 @@
         </p:blipFill>
         <p:spPr>
           <a:xfrm>
-            <a:off x="3246120" y="1143000"/>
-            <a:ext cx="2697480" cy="4023360"/>
+            <a:off x="3246120" y="1097280"/>
+            <a:ext cx="2743200" cy="3977639"/>
           </a:xfrm>
           <a:prstGeom prst="rect">
             <a:avLst/>
@@ -9623,8 +8712,8 @@
         </p:nvSpPr>
         <p:spPr>
           <a:xfrm>
-            <a:off x="3246120" y="5212080"/>
-            <a:ext cx="2697480" cy="320040"/>
+            <a:off x="3246120" y="5120640"/>
+            <a:ext cx="2743200" cy="292608"/>
           </a:xfrm>
           <a:prstGeom prst="rect">
             <a:avLst/>
@@ -9643,15 +8732,16 @@
                 <a:solidFill>
                   <a:srgbClr val="BC6288"/>
                 </a:solidFill>
+                <a:latin typeface="Calibri"/>
               </a:rPr>
-              <a:t>Shop</a:t>
+              <a:t>Accueil</a:t>
             </a:r>
           </a:p>
         </p:txBody>
       </p:sp>
       <p:pic>
         <p:nvPicPr>
-          <p:cNvPr id="12" name="Picture 11" descr="checkout.png"/>
+          <p:cNvPr id="12" name="Picture 11" descr="mockup-shop.png"/>
           <p:cNvPicPr>
             <a:picLocks noChangeAspect="1"/>
           </p:cNvPicPr>
@@ -9665,8 +8755,8 @@
         </p:blipFill>
         <p:spPr>
           <a:xfrm>
-            <a:off x="6126480" y="1143000"/>
-            <a:ext cx="2697480" cy="4023360"/>
+            <a:off x="6172200" y="1097280"/>
+            <a:ext cx="2743200" cy="3977639"/>
           </a:xfrm>
           <a:prstGeom prst="rect">
             <a:avLst/>
@@ -9681,8 +8771,8 @@
         </p:nvSpPr>
         <p:spPr>
           <a:xfrm>
-            <a:off x="6126480" y="5212080"/>
-            <a:ext cx="2697480" cy="320040"/>
+            <a:off x="6172200" y="5120640"/>
+            <a:ext cx="2743200" cy="292608"/>
           </a:xfrm>
           <a:prstGeom prst="rect">
             <a:avLst/>
@@ -9701,15 +8791,16 @@
                 <a:solidFill>
                   <a:srgbClr val="BC6288"/>
                 </a:solidFill>
+                <a:latin typeface="Calibri"/>
               </a:rPr>
-              <a:t>Checkout</a:t>
+              <a:t>Shop</a:t>
             </a:r>
           </a:p>
         </p:txBody>
       </p:sp>
       <p:pic>
         <p:nvPicPr>
-          <p:cNvPr id="14" name="Picture 13" descr="admin-orders.png"/>
+          <p:cNvPr id="14" name="Picture 13" descr="mockup-checkout.png"/>
           <p:cNvPicPr>
             <a:picLocks noChangeAspect="1"/>
           </p:cNvPicPr>
@@ -9723,8 +8814,8 @@
         </p:blipFill>
         <p:spPr>
           <a:xfrm>
-            <a:off x="9006840" y="1143000"/>
-            <a:ext cx="2697480" cy="4023360"/>
+            <a:off x="9098280" y="1097280"/>
+            <a:ext cx="2743200" cy="3977639"/>
           </a:xfrm>
           <a:prstGeom prst="rect">
             <a:avLst/>
@@ -9739,8 +8830,8 @@
         </p:nvSpPr>
         <p:spPr>
           <a:xfrm>
-            <a:off x="9006840" y="5212080"/>
-            <a:ext cx="2697480" cy="320040"/>
+            <a:off x="9098280" y="5120640"/>
+            <a:ext cx="2743200" cy="292608"/>
           </a:xfrm>
           <a:prstGeom prst="rect">
             <a:avLst/>
@@ -9759,8 +8850,9 @@
                 <a:solidFill>
                   <a:srgbClr val="BC6288"/>
                 </a:solidFill>
+                <a:latin typeface="Calibri"/>
               </a:rPr>
-              <a:t>Admin FAC</a:t>
+              <a:t>Paiement</a:t>
             </a:r>
           </a:p>
         </p:txBody>
@@ -9975,7 +9067,7 @@
                 </a:solidFill>
                 <a:latin typeface="Calibri"/>
               </a:rPr>
-              <a:t>CONCLUSION</a:t>
+              <a:t>MAQUETTE</a:t>
             </a:r>
           </a:p>
         </p:txBody>
@@ -10009,21 +9101,45 @@
                 </a:solidFill>
                 <a:latin typeface="Calibri"/>
               </a:rPr>
-              <a:t>A florist shop that takes money and can be explained</a:t>
-            </a:r>
-          </a:p>
-        </p:txBody>
-      </p:sp>
-      <p:sp>
-        <p:nvSpPr>
-          <p:cNvPr id="8" name="TextBox 7"/>
+              <a:t>Panier, commandes, admin FAC, mobile</a:t>
+            </a:r>
+          </a:p>
+        </p:txBody>
+      </p:sp>
+      <p:pic>
+        <p:nvPicPr>
+          <p:cNvPr id="8" name="Picture 7" descr="mockup-panier.png"/>
+          <p:cNvPicPr>
+            <a:picLocks noChangeAspect="1"/>
+          </p:cNvPicPr>
+          <p:nvPr/>
+        </p:nvPicPr>
+        <p:blipFill>
+          <a:blip r:embed="rId2"/>
+          <a:stretch>
+            <a:fillRect/>
+          </a:stretch>
+        </p:blipFill>
+        <p:spPr>
+          <a:xfrm>
+            <a:off x="320040" y="1097280"/>
+            <a:ext cx="2743200" cy="3977639"/>
+          </a:xfrm>
+          <a:prstGeom prst="rect">
+            <a:avLst/>
+          </a:prstGeom>
+        </p:spPr>
+      </p:pic>
+      <p:sp>
+        <p:nvSpPr>
+          <p:cNvPr id="9" name="TextBox 8"/>
           <p:cNvSpPr txBox="1"/>
           <p:nvPr/>
         </p:nvSpPr>
         <p:spPr>
           <a:xfrm>
-            <a:off x="411480" y="1097280"/>
-            <a:ext cx="11338560" cy="5029200"/>
+            <a:off x="320040" y="5120640"/>
+            <a:ext cx="2743200" cy="292608"/>
           </a:xfrm>
           <a:prstGeom prst="rect">
             <a:avLst/>
@@ -10031,72 +9147,197 @@
           <a:noFill/>
         </p:spPr>
         <p:txBody>
-          <a:bodyPr wrap="square">
+          <a:bodyPr wrap="none">
             <a:spAutoFit/>
           </a:bodyPr>
           <a:lstStyle/>
           <a:p>
-            <a:pPr>
-              <a:spcAft>
-                <a:spcPts val="800"/>
-              </a:spcAft>
-              <a:defRPr sz="1800">
-                <a:solidFill>
-                  <a:srgbClr val="3A2A30"/>
-                </a:solidFill>
-                <a:latin typeface="Calibri"/>
-              </a:defRPr>
-            </a:pPr>
-            <a:r>
-              <a:t>A customer can sign in, buy a photographed bouquet, pay or leave a deposit, subscribe, and track.</a:t>
-            </a:r>
-          </a:p>
-          <a:p>
-            <a:pPr>
-              <a:spcAft>
-                <a:spcPts val="800"/>
-              </a:spcAft>
-              <a:defRPr sz="1800">
-                <a:solidFill>
-                  <a:srgbClr val="3A2A30"/>
-                </a:solidFill>
-                <a:latin typeface="Calibri"/>
-              </a:defRPr>
-            </a:pPr>
-            <a:r>
-              <a:t>The florist manages catalog, vitrine, and a printable TTC invoice — not a fake 20 % TVA.</a:t>
-            </a:r>
-          </a:p>
-          <a:p>
-            <a:pPr>
-              <a:spcAft>
-                <a:spcPts val="800"/>
-              </a:spcAft>
-              <a:defRPr sz="1800">
-                <a:solidFill>
-                  <a:srgbClr val="3A2A30"/>
-                </a:solidFill>
-                <a:latin typeface="Calibri"/>
-              </a:defRPr>
-            </a:pPr>
-            <a:r>
-              <a:t>Gaps from the original Wix spec are written down. 80 tests. Secrets stay out of Git.</a:t>
-            </a:r>
-          </a:p>
-          <a:p>
-            <a:pPr>
-              <a:spcAft>
-                <a:spcPts val="800"/>
-              </a:spcAft>
-              <a:defRPr sz="1800">
-                <a:solidFill>
-                  <a:srgbClr val="3A2A30"/>
-                </a:solidFill>
-                <a:latin typeface="Calibri"/>
-              </a:defRPr>
-            </a:pPr>
-            <a:r>
-              <a:t>Next slice: operations (delivery, email, hosting), not another visual pass.</a:t>
+            <a:pPr algn="ctr"/>
+            <a:r>
+              <a:rPr sz="1200" b="1">
+                <a:solidFill>
+                  <a:srgbClr val="BC6288"/>
+                </a:solidFill>
+                <a:latin typeface="Calibri"/>
+              </a:rPr>
+              <a:t>Panier</a:t>
+            </a:r>
+          </a:p>
+        </p:txBody>
+      </p:sp>
+      <p:pic>
+        <p:nvPicPr>
+          <p:cNvPr id="10" name="Picture 9" descr="mockup-commandes.png"/>
+          <p:cNvPicPr>
+            <a:picLocks noChangeAspect="1"/>
+          </p:cNvPicPr>
+          <p:nvPr/>
+        </p:nvPicPr>
+        <p:blipFill>
+          <a:blip r:embed="rId3"/>
+          <a:stretch>
+            <a:fillRect/>
+          </a:stretch>
+        </p:blipFill>
+        <p:spPr>
+          <a:xfrm>
+            <a:off x="3246120" y="1097280"/>
+            <a:ext cx="2743200" cy="3977639"/>
+          </a:xfrm>
+          <a:prstGeom prst="rect">
+            <a:avLst/>
+          </a:prstGeom>
+        </p:spPr>
+      </p:pic>
+      <p:sp>
+        <p:nvSpPr>
+          <p:cNvPr id="11" name="TextBox 10"/>
+          <p:cNvSpPr txBox="1"/>
+          <p:nvPr/>
+        </p:nvSpPr>
+        <p:spPr>
+          <a:xfrm>
+            <a:off x="3246120" y="5120640"/>
+            <a:ext cx="2743200" cy="292608"/>
+          </a:xfrm>
+          <a:prstGeom prst="rect">
+            <a:avLst/>
+          </a:prstGeom>
+          <a:noFill/>
+        </p:spPr>
+        <p:txBody>
+          <a:bodyPr wrap="none">
+            <a:spAutoFit/>
+          </a:bodyPr>
+          <a:lstStyle/>
+          <a:p>
+            <a:pPr algn="ctr"/>
+            <a:r>
+              <a:rPr sz="1200" b="1">
+                <a:solidFill>
+                  <a:srgbClr val="BC6288"/>
+                </a:solidFill>
+                <a:latin typeface="Calibri"/>
+              </a:rPr>
+              <a:t>Mes commandes</a:t>
+            </a:r>
+          </a:p>
+        </p:txBody>
+      </p:sp>
+      <p:pic>
+        <p:nvPicPr>
+          <p:cNvPr id="12" name="Picture 11" descr="mockup-admin-facture.png"/>
+          <p:cNvPicPr>
+            <a:picLocks noChangeAspect="1"/>
+          </p:cNvPicPr>
+          <p:nvPr/>
+        </p:nvPicPr>
+        <p:blipFill>
+          <a:blip r:embed="rId4"/>
+          <a:stretch>
+            <a:fillRect/>
+          </a:stretch>
+        </p:blipFill>
+        <p:spPr>
+          <a:xfrm>
+            <a:off x="6172200" y="1097280"/>
+            <a:ext cx="2743200" cy="3977639"/>
+          </a:xfrm>
+          <a:prstGeom prst="rect">
+            <a:avLst/>
+          </a:prstGeom>
+        </p:spPr>
+      </p:pic>
+      <p:sp>
+        <p:nvSpPr>
+          <p:cNvPr id="13" name="TextBox 12"/>
+          <p:cNvSpPr txBox="1"/>
+          <p:nvPr/>
+        </p:nvSpPr>
+        <p:spPr>
+          <a:xfrm>
+            <a:off x="6172200" y="5120640"/>
+            <a:ext cx="2743200" cy="292608"/>
+          </a:xfrm>
+          <a:prstGeom prst="rect">
+            <a:avLst/>
+          </a:prstGeom>
+          <a:noFill/>
+        </p:spPr>
+        <p:txBody>
+          <a:bodyPr wrap="none">
+            <a:spAutoFit/>
+          </a:bodyPr>
+          <a:lstStyle/>
+          <a:p>
+            <a:pPr algn="ctr"/>
+            <a:r>
+              <a:rPr sz="1200" b="1">
+                <a:solidFill>
+                  <a:srgbClr val="BC6288"/>
+                </a:solidFill>
+                <a:latin typeface="Calibri"/>
+              </a:rPr>
+              <a:t>Facture FAC</a:t>
+            </a:r>
+          </a:p>
+        </p:txBody>
+      </p:sp>
+      <p:pic>
+        <p:nvPicPr>
+          <p:cNvPr id="14" name="Picture 13" descr="mockup-shop-mobile.png"/>
+          <p:cNvPicPr>
+            <a:picLocks noChangeAspect="1"/>
+          </p:cNvPicPr>
+          <p:nvPr/>
+        </p:nvPicPr>
+        <p:blipFill>
+          <a:blip r:embed="rId5"/>
+          <a:stretch>
+            <a:fillRect/>
+          </a:stretch>
+        </p:blipFill>
+        <p:spPr>
+          <a:xfrm>
+            <a:off x="9189720" y="1051560"/>
+            <a:ext cx="2606040" cy="4617720"/>
+          </a:xfrm>
+          <a:prstGeom prst="rect">
+            <a:avLst/>
+          </a:prstGeom>
+        </p:spPr>
+      </p:pic>
+      <p:sp>
+        <p:nvSpPr>
+          <p:cNvPr id="15" name="TextBox 14"/>
+          <p:cNvSpPr txBox="1"/>
+          <p:nvPr/>
+        </p:nvSpPr>
+        <p:spPr>
+          <a:xfrm>
+            <a:off x="9189720" y="5687568"/>
+            <a:ext cx="2606040" cy="292608"/>
+          </a:xfrm>
+          <a:prstGeom prst="rect">
+            <a:avLst/>
+          </a:prstGeom>
+          <a:noFill/>
+        </p:spPr>
+        <p:txBody>
+          <a:bodyPr wrap="none">
+            <a:spAutoFit/>
+          </a:bodyPr>
+          <a:lstStyle/>
+          <a:p>
+            <a:pPr algn="ctr"/>
+            <a:r>
+              <a:rPr sz="1200" b="1">
+                <a:solidFill>
+                  <a:srgbClr val="BC6288"/>
+                </a:solidFill>
+                <a:latin typeface="Calibri"/>
+              </a:rPr>
+              <a:t>Shop mobile</a:t>
             </a:r>
           </a:p>
         </p:txBody>
@@ -10110,6 +9351,768 @@
 </file>
 
 <file path=ppt/slides/slide22.xml><?xml version="1.0" encoding="utf-8"?>
+<p:sld xmlns:a="http://schemas.openxmlformats.org/drawingml/2006/main" xmlns:p="http://schemas.openxmlformats.org/presentationml/2006/main" xmlns:r="http://schemas.openxmlformats.org/officeDocument/2006/relationships">
+  <p:cSld>
+    <p:spTree>
+      <p:nvGrpSpPr>
+        <p:cNvPr id="1" name=""/>
+        <p:cNvGrpSpPr/>
+        <p:nvPr/>
+      </p:nvGrpSpPr>
+      <p:grpSpPr/>
+      <p:sp>
+        <p:nvSpPr>
+          <p:cNvPr id="2" name="Rectangle 1"/>
+          <p:cNvSpPr/>
+          <p:nvPr/>
+        </p:nvSpPr>
+        <p:spPr>
+          <a:xfrm>
+            <a:off x="0" y="0"/>
+            <a:ext cx="12191695" cy="6858000"/>
+          </a:xfrm>
+          <a:prstGeom prst="rect">
+            <a:avLst/>
+          </a:prstGeom>
+          <a:solidFill>
+            <a:srgbClr val="FDFAF8"/>
+          </a:solidFill>
+          <a:ln>
+            <a:noFill/>
+          </a:ln>
+        </p:spPr>
+        <p:style>
+          <a:lnRef idx="1">
+            <a:schemeClr val="accent1"/>
+          </a:lnRef>
+          <a:fillRef idx="3">
+            <a:schemeClr val="accent1"/>
+          </a:fillRef>
+          <a:effectRef idx="2">
+            <a:schemeClr val="accent1"/>
+          </a:effectRef>
+          <a:fontRef idx="minor">
+            <a:schemeClr val="lt1"/>
+          </a:fontRef>
+        </p:style>
+        <p:txBody>
+          <a:bodyPr rtlCol="0" anchor="ctr"/>
+          <a:lstStyle/>
+          <a:p>
+            <a:pPr algn="ctr"/>
+          </a:p>
+        </p:txBody>
+      </p:sp>
+      <p:sp>
+        <p:nvSpPr>
+          <p:cNvPr id="3" name="Rectangle 2"/>
+          <p:cNvSpPr/>
+          <p:nvPr/>
+        </p:nvSpPr>
+        <p:spPr>
+          <a:xfrm>
+            <a:off x="0" y="0"/>
+            <a:ext cx="12191695" cy="109728"/>
+          </a:xfrm>
+          <a:prstGeom prst="rect">
+            <a:avLst/>
+          </a:prstGeom>
+          <a:solidFill>
+            <a:srgbClr val="BC6288"/>
+          </a:solidFill>
+          <a:ln>
+            <a:noFill/>
+          </a:ln>
+        </p:spPr>
+        <p:style>
+          <a:lnRef idx="1">
+            <a:schemeClr val="accent1"/>
+          </a:lnRef>
+          <a:fillRef idx="3">
+            <a:schemeClr val="accent1"/>
+          </a:fillRef>
+          <a:effectRef idx="2">
+            <a:schemeClr val="accent1"/>
+          </a:effectRef>
+          <a:fontRef idx="minor">
+            <a:schemeClr val="lt1"/>
+          </a:fontRef>
+        </p:style>
+        <p:txBody>
+          <a:bodyPr rtlCol="0" anchor="ctr"/>
+          <a:lstStyle/>
+          <a:p>
+            <a:pPr algn="ctr"/>
+          </a:p>
+        </p:txBody>
+      </p:sp>
+      <p:sp>
+        <p:nvSpPr>
+          <p:cNvPr id="4" name="Rectangle 3"/>
+          <p:cNvSpPr/>
+          <p:nvPr/>
+        </p:nvSpPr>
+        <p:spPr>
+          <a:xfrm>
+            <a:off x="0" y="6510528"/>
+            <a:ext cx="12191695" cy="347472"/>
+          </a:xfrm>
+          <a:prstGeom prst="rect">
+            <a:avLst/>
+          </a:prstGeom>
+          <a:solidFill>
+            <a:srgbClr val="7F3F5A"/>
+          </a:solidFill>
+          <a:ln>
+            <a:noFill/>
+          </a:ln>
+        </p:spPr>
+        <p:style>
+          <a:lnRef idx="1">
+            <a:schemeClr val="accent1"/>
+          </a:lnRef>
+          <a:fillRef idx="3">
+            <a:schemeClr val="accent1"/>
+          </a:fillRef>
+          <a:effectRef idx="2">
+            <a:schemeClr val="accent1"/>
+          </a:effectRef>
+          <a:fontRef idx="minor">
+            <a:schemeClr val="lt1"/>
+          </a:fontRef>
+        </p:style>
+        <p:txBody>
+          <a:bodyPr rtlCol="0" anchor="ctr"/>
+          <a:lstStyle/>
+          <a:p>
+            <a:pPr algn="ctr"/>
+          </a:p>
+        </p:txBody>
+      </p:sp>
+      <p:sp>
+        <p:nvSpPr>
+          <p:cNvPr id="5" name="TextBox 4"/>
+          <p:cNvSpPr txBox="1"/>
+          <p:nvPr/>
+        </p:nvSpPr>
+        <p:spPr>
+          <a:xfrm>
+            <a:off x="365760" y="6528816"/>
+            <a:ext cx="9144000" cy="292608"/>
+          </a:xfrm>
+          <a:prstGeom prst="rect">
+            <a:avLst/>
+          </a:prstGeom>
+          <a:noFill/>
+        </p:spPr>
+        <p:txBody>
+          <a:bodyPr wrap="none">
+            <a:spAutoFit/>
+          </a:bodyPr>
+          <a:lstStyle/>
+          <a:p>
+            <a:r>
+              <a:rPr sz="1100">
+                <a:solidFill>
+                  <a:srgbClr val="FFFFFF"/>
+                </a:solidFill>
+                <a:latin typeface="Calibri"/>
+              </a:rPr>
+              <a:t>Pivoine &amp; Lilas  ·  Sciez / Léman  ·  Dimitri Jaille &amp; Mattieu Mouroux</a:t>
+            </a:r>
+          </a:p>
+        </p:txBody>
+      </p:sp>
+      <p:sp>
+        <p:nvSpPr>
+          <p:cNvPr id="6" name="TextBox 5"/>
+          <p:cNvSpPr txBox="1"/>
+          <p:nvPr/>
+        </p:nvSpPr>
+        <p:spPr>
+          <a:xfrm>
+            <a:off x="411480" y="256032"/>
+            <a:ext cx="11338560" cy="292608"/>
+          </a:xfrm>
+          <a:prstGeom prst="rect">
+            <a:avLst/>
+          </a:prstGeom>
+          <a:noFill/>
+        </p:spPr>
+        <p:txBody>
+          <a:bodyPr wrap="none">
+            <a:spAutoFit/>
+          </a:bodyPr>
+          <a:lstStyle/>
+          <a:p>
+            <a:r>
+              <a:rPr sz="1200" b="1">
+                <a:solidFill>
+                  <a:srgbClr val="BC6288"/>
+                </a:solidFill>
+                <a:latin typeface="Calibri"/>
+              </a:rPr>
+              <a:t>MAQUETTE</a:t>
+            </a:r>
+          </a:p>
+        </p:txBody>
+      </p:sp>
+      <p:sp>
+        <p:nvSpPr>
+          <p:cNvPr id="7" name="TextBox 6"/>
+          <p:cNvSpPr txBox="1"/>
+          <p:nvPr/>
+        </p:nvSpPr>
+        <p:spPr>
+          <a:xfrm>
+            <a:off x="411480" y="475488"/>
+            <a:ext cx="11338560" cy="502920"/>
+          </a:xfrm>
+          <a:prstGeom prst="rect">
+            <a:avLst/>
+          </a:prstGeom>
+          <a:noFill/>
+        </p:spPr>
+        <p:txBody>
+          <a:bodyPr wrap="none">
+            <a:spAutoFit/>
+          </a:bodyPr>
+          <a:lstStyle/>
+          <a:p>
+            <a:r>
+              <a:rPr sz="2800" b="1">
+                <a:solidFill>
+                  <a:srgbClr val="3A2A30"/>
+                </a:solidFill>
+                <a:latin typeface="Calibri"/>
+              </a:rPr>
+              <a:t>Connexion, vitrine admin, panier vide</a:t>
+            </a:r>
+          </a:p>
+        </p:txBody>
+      </p:sp>
+      <p:pic>
+        <p:nvPicPr>
+          <p:cNvPr id="8" name="Picture 7" descr="mockup-login.png"/>
+          <p:cNvPicPr>
+            <a:picLocks noChangeAspect="1"/>
+          </p:cNvPicPr>
+          <p:nvPr/>
+        </p:nvPicPr>
+        <p:blipFill>
+          <a:blip r:embed="rId2"/>
+          <a:stretch>
+            <a:fillRect/>
+          </a:stretch>
+        </p:blipFill>
+        <p:spPr>
+          <a:xfrm>
+            <a:off x="365760" y="1097280"/>
+            <a:ext cx="3383280" cy="4023360"/>
+          </a:xfrm>
+          <a:prstGeom prst="rect">
+            <a:avLst/>
+          </a:prstGeom>
+        </p:spPr>
+      </p:pic>
+      <p:sp>
+        <p:nvSpPr>
+          <p:cNvPr id="9" name="TextBox 8"/>
+          <p:cNvSpPr txBox="1"/>
+          <p:nvPr/>
+        </p:nvSpPr>
+        <p:spPr>
+          <a:xfrm>
+            <a:off x="365760" y="5166360"/>
+            <a:ext cx="3383280" cy="292608"/>
+          </a:xfrm>
+          <a:prstGeom prst="rect">
+            <a:avLst/>
+          </a:prstGeom>
+          <a:noFill/>
+        </p:spPr>
+        <p:txBody>
+          <a:bodyPr wrap="none">
+            <a:spAutoFit/>
+          </a:bodyPr>
+          <a:lstStyle/>
+          <a:p>
+            <a:pPr algn="ctr"/>
+            <a:r>
+              <a:rPr sz="1200" b="1">
+                <a:solidFill>
+                  <a:srgbClr val="BC6288"/>
+                </a:solidFill>
+                <a:latin typeface="Calibri"/>
+              </a:rPr>
+              <a:t>Connexion</a:t>
+            </a:r>
+          </a:p>
+        </p:txBody>
+      </p:sp>
+      <p:pic>
+        <p:nvPicPr>
+          <p:cNvPr id="10" name="Picture 9" descr="mockup-admin-vitrine.png"/>
+          <p:cNvPicPr>
+            <a:picLocks noChangeAspect="1"/>
+          </p:cNvPicPr>
+          <p:nvPr/>
+        </p:nvPicPr>
+        <p:blipFill>
+          <a:blip r:embed="rId3"/>
+          <a:stretch>
+            <a:fillRect/>
+          </a:stretch>
+        </p:blipFill>
+        <p:spPr>
+          <a:xfrm>
+            <a:off x="4160520" y="1097280"/>
+            <a:ext cx="3383280" cy="4023360"/>
+          </a:xfrm>
+          <a:prstGeom prst="rect">
+            <a:avLst/>
+          </a:prstGeom>
+        </p:spPr>
+      </p:pic>
+      <p:sp>
+        <p:nvSpPr>
+          <p:cNvPr id="11" name="TextBox 10"/>
+          <p:cNvSpPr txBox="1"/>
+          <p:nvPr/>
+        </p:nvSpPr>
+        <p:spPr>
+          <a:xfrm>
+            <a:off x="4160520" y="5166360"/>
+            <a:ext cx="3383280" cy="292608"/>
+          </a:xfrm>
+          <a:prstGeom prst="rect">
+            <a:avLst/>
+          </a:prstGeom>
+          <a:noFill/>
+        </p:spPr>
+        <p:txBody>
+          <a:bodyPr wrap="none">
+            <a:spAutoFit/>
+          </a:bodyPr>
+          <a:lstStyle/>
+          <a:p>
+            <a:pPr algn="ctr"/>
+            <a:r>
+              <a:rPr sz="1200" b="1">
+                <a:solidFill>
+                  <a:srgbClr val="BC6288"/>
+                </a:solidFill>
+                <a:latin typeface="Calibri"/>
+              </a:rPr>
+              <a:t>Vitrine admin</a:t>
+            </a:r>
+          </a:p>
+        </p:txBody>
+      </p:sp>
+      <p:pic>
+        <p:nvPicPr>
+          <p:cNvPr id="12" name="Picture 11" descr="mockup-panier-vide-mobile.png"/>
+          <p:cNvPicPr>
+            <a:picLocks noChangeAspect="1"/>
+          </p:cNvPicPr>
+          <p:nvPr/>
+        </p:nvPicPr>
+        <p:blipFill>
+          <a:blip r:embed="rId4"/>
+          <a:stretch>
+            <a:fillRect/>
+          </a:stretch>
+        </p:blipFill>
+        <p:spPr>
+          <a:xfrm>
+            <a:off x="7955279" y="1097280"/>
+            <a:ext cx="3017520" cy="4572000"/>
+          </a:xfrm>
+          <a:prstGeom prst="rect">
+            <a:avLst/>
+          </a:prstGeom>
+        </p:spPr>
+      </p:pic>
+      <p:sp>
+        <p:nvSpPr>
+          <p:cNvPr id="13" name="TextBox 12"/>
+          <p:cNvSpPr txBox="1"/>
+          <p:nvPr/>
+        </p:nvSpPr>
+        <p:spPr>
+          <a:xfrm>
+            <a:off x="7955279" y="5687568"/>
+            <a:ext cx="3017520" cy="292608"/>
+          </a:xfrm>
+          <a:prstGeom prst="rect">
+            <a:avLst/>
+          </a:prstGeom>
+          <a:noFill/>
+        </p:spPr>
+        <p:txBody>
+          <a:bodyPr wrap="none">
+            <a:spAutoFit/>
+          </a:bodyPr>
+          <a:lstStyle/>
+          <a:p>
+            <a:pPr algn="ctr"/>
+            <a:r>
+              <a:rPr sz="1200" b="1">
+                <a:solidFill>
+                  <a:srgbClr val="BC6288"/>
+                </a:solidFill>
+                <a:latin typeface="Calibri"/>
+              </a:rPr>
+              <a:t>Panier vide mobile</a:t>
+            </a:r>
+          </a:p>
+        </p:txBody>
+      </p:sp>
+    </p:spTree>
+  </p:cSld>
+  <p:clrMapOvr>
+    <a:masterClrMapping/>
+  </p:clrMapOvr>
+</p:sld>
+</file>
+
+<file path=ppt/slides/slide23.xml><?xml version="1.0" encoding="utf-8"?>
+<p:sld xmlns:a="http://schemas.openxmlformats.org/drawingml/2006/main" xmlns:p="http://schemas.openxmlformats.org/presentationml/2006/main" xmlns:r="http://schemas.openxmlformats.org/officeDocument/2006/relationships">
+  <p:cSld>
+    <p:spTree>
+      <p:nvGrpSpPr>
+        <p:cNvPr id="1" name=""/>
+        <p:cNvGrpSpPr/>
+        <p:nvPr/>
+      </p:nvGrpSpPr>
+      <p:grpSpPr/>
+      <p:sp>
+        <p:nvSpPr>
+          <p:cNvPr id="2" name="Rectangle 1"/>
+          <p:cNvSpPr/>
+          <p:nvPr/>
+        </p:nvSpPr>
+        <p:spPr>
+          <a:xfrm>
+            <a:off x="0" y="0"/>
+            <a:ext cx="12191695" cy="6858000"/>
+          </a:xfrm>
+          <a:prstGeom prst="rect">
+            <a:avLst/>
+          </a:prstGeom>
+          <a:solidFill>
+            <a:srgbClr val="FDFAF8"/>
+          </a:solidFill>
+          <a:ln>
+            <a:noFill/>
+          </a:ln>
+        </p:spPr>
+        <p:style>
+          <a:lnRef idx="1">
+            <a:schemeClr val="accent1"/>
+          </a:lnRef>
+          <a:fillRef idx="3">
+            <a:schemeClr val="accent1"/>
+          </a:fillRef>
+          <a:effectRef idx="2">
+            <a:schemeClr val="accent1"/>
+          </a:effectRef>
+          <a:fontRef idx="minor">
+            <a:schemeClr val="lt1"/>
+          </a:fontRef>
+        </p:style>
+        <p:txBody>
+          <a:bodyPr rtlCol="0" anchor="ctr"/>
+          <a:lstStyle/>
+          <a:p>
+            <a:pPr algn="ctr"/>
+          </a:p>
+        </p:txBody>
+      </p:sp>
+      <p:sp>
+        <p:nvSpPr>
+          <p:cNvPr id="3" name="Rectangle 2"/>
+          <p:cNvSpPr/>
+          <p:nvPr/>
+        </p:nvSpPr>
+        <p:spPr>
+          <a:xfrm>
+            <a:off x="0" y="0"/>
+            <a:ext cx="12191695" cy="109728"/>
+          </a:xfrm>
+          <a:prstGeom prst="rect">
+            <a:avLst/>
+          </a:prstGeom>
+          <a:solidFill>
+            <a:srgbClr val="BC6288"/>
+          </a:solidFill>
+          <a:ln>
+            <a:noFill/>
+          </a:ln>
+        </p:spPr>
+        <p:style>
+          <a:lnRef idx="1">
+            <a:schemeClr val="accent1"/>
+          </a:lnRef>
+          <a:fillRef idx="3">
+            <a:schemeClr val="accent1"/>
+          </a:fillRef>
+          <a:effectRef idx="2">
+            <a:schemeClr val="accent1"/>
+          </a:effectRef>
+          <a:fontRef idx="minor">
+            <a:schemeClr val="lt1"/>
+          </a:fontRef>
+        </p:style>
+        <p:txBody>
+          <a:bodyPr rtlCol="0" anchor="ctr"/>
+          <a:lstStyle/>
+          <a:p>
+            <a:pPr algn="ctr"/>
+          </a:p>
+        </p:txBody>
+      </p:sp>
+      <p:sp>
+        <p:nvSpPr>
+          <p:cNvPr id="4" name="Rectangle 3"/>
+          <p:cNvSpPr/>
+          <p:nvPr/>
+        </p:nvSpPr>
+        <p:spPr>
+          <a:xfrm>
+            <a:off x="0" y="6510528"/>
+            <a:ext cx="12191695" cy="347472"/>
+          </a:xfrm>
+          <a:prstGeom prst="rect">
+            <a:avLst/>
+          </a:prstGeom>
+          <a:solidFill>
+            <a:srgbClr val="7F3F5A"/>
+          </a:solidFill>
+          <a:ln>
+            <a:noFill/>
+          </a:ln>
+        </p:spPr>
+        <p:style>
+          <a:lnRef idx="1">
+            <a:schemeClr val="accent1"/>
+          </a:lnRef>
+          <a:fillRef idx="3">
+            <a:schemeClr val="accent1"/>
+          </a:fillRef>
+          <a:effectRef idx="2">
+            <a:schemeClr val="accent1"/>
+          </a:effectRef>
+          <a:fontRef idx="minor">
+            <a:schemeClr val="lt1"/>
+          </a:fontRef>
+        </p:style>
+        <p:txBody>
+          <a:bodyPr rtlCol="0" anchor="ctr"/>
+          <a:lstStyle/>
+          <a:p>
+            <a:pPr algn="ctr"/>
+          </a:p>
+        </p:txBody>
+      </p:sp>
+      <p:sp>
+        <p:nvSpPr>
+          <p:cNvPr id="5" name="TextBox 4"/>
+          <p:cNvSpPr txBox="1"/>
+          <p:nvPr/>
+        </p:nvSpPr>
+        <p:spPr>
+          <a:xfrm>
+            <a:off x="365760" y="6528816"/>
+            <a:ext cx="9144000" cy="292608"/>
+          </a:xfrm>
+          <a:prstGeom prst="rect">
+            <a:avLst/>
+          </a:prstGeom>
+          <a:noFill/>
+        </p:spPr>
+        <p:txBody>
+          <a:bodyPr wrap="none">
+            <a:spAutoFit/>
+          </a:bodyPr>
+          <a:lstStyle/>
+          <a:p>
+            <a:r>
+              <a:rPr sz="1100">
+                <a:solidFill>
+                  <a:srgbClr val="FFFFFF"/>
+                </a:solidFill>
+                <a:latin typeface="Calibri"/>
+              </a:rPr>
+              <a:t>Pivoine &amp; Lilas  ·  Sciez / Léman  ·  Dimitri Jaille &amp; Mattieu Mouroux</a:t>
+            </a:r>
+          </a:p>
+        </p:txBody>
+      </p:sp>
+      <p:sp>
+        <p:nvSpPr>
+          <p:cNvPr id="6" name="TextBox 5"/>
+          <p:cNvSpPr txBox="1"/>
+          <p:nvPr/>
+        </p:nvSpPr>
+        <p:spPr>
+          <a:xfrm>
+            <a:off x="411480" y="256032"/>
+            <a:ext cx="11338560" cy="292608"/>
+          </a:xfrm>
+          <a:prstGeom prst="rect">
+            <a:avLst/>
+          </a:prstGeom>
+          <a:noFill/>
+        </p:spPr>
+        <p:txBody>
+          <a:bodyPr wrap="none">
+            <a:spAutoFit/>
+          </a:bodyPr>
+          <a:lstStyle/>
+          <a:p>
+            <a:r>
+              <a:rPr sz="1200" b="1">
+                <a:solidFill>
+                  <a:srgbClr val="BC6288"/>
+                </a:solidFill>
+                <a:latin typeface="Calibri"/>
+              </a:rPr>
+              <a:t>CONCLUSION</a:t>
+            </a:r>
+          </a:p>
+        </p:txBody>
+      </p:sp>
+      <p:sp>
+        <p:nvSpPr>
+          <p:cNvPr id="7" name="TextBox 6"/>
+          <p:cNvSpPr txBox="1"/>
+          <p:nvPr/>
+        </p:nvSpPr>
+        <p:spPr>
+          <a:xfrm>
+            <a:off x="411480" y="475488"/>
+            <a:ext cx="11338560" cy="502920"/>
+          </a:xfrm>
+          <a:prstGeom prst="rect">
+            <a:avLst/>
+          </a:prstGeom>
+          <a:noFill/>
+        </p:spPr>
+        <p:txBody>
+          <a:bodyPr wrap="none">
+            <a:spAutoFit/>
+          </a:bodyPr>
+          <a:lstStyle/>
+          <a:p>
+            <a:r>
+              <a:rPr sz="2800" b="1">
+                <a:solidFill>
+                  <a:srgbClr val="3A2A30"/>
+                </a:solidFill>
+                <a:latin typeface="Calibri"/>
+              </a:rPr>
+              <a:t>A florist shop that takes money and can be explained</a:t>
+            </a:r>
+          </a:p>
+        </p:txBody>
+      </p:sp>
+      <p:sp>
+        <p:nvSpPr>
+          <p:cNvPr id="8" name="TextBox 7"/>
+          <p:cNvSpPr txBox="1"/>
+          <p:nvPr/>
+        </p:nvSpPr>
+        <p:spPr>
+          <a:xfrm>
+            <a:off x="411480" y="1097280"/>
+            <a:ext cx="11338560" cy="5029200"/>
+          </a:xfrm>
+          <a:prstGeom prst="rect">
+            <a:avLst/>
+          </a:prstGeom>
+          <a:noFill/>
+        </p:spPr>
+        <p:txBody>
+          <a:bodyPr wrap="square">
+            <a:spAutoFit/>
+          </a:bodyPr>
+          <a:lstStyle/>
+          <a:p>
+            <a:pPr>
+              <a:spcAft>
+                <a:spcPts val="800"/>
+              </a:spcAft>
+              <a:defRPr sz="1800">
+                <a:solidFill>
+                  <a:srgbClr val="3A2A30"/>
+                </a:solidFill>
+                <a:latin typeface="Calibri"/>
+              </a:defRPr>
+            </a:pPr>
+            <a:r>
+              <a:t>A customer can sign in, buy a photographed bouquet, pay or leave a deposit, subscribe, and track.</a:t>
+            </a:r>
+          </a:p>
+          <a:p>
+            <a:pPr>
+              <a:spcAft>
+                <a:spcPts val="800"/>
+              </a:spcAft>
+              <a:defRPr sz="1800">
+                <a:solidFill>
+                  <a:srgbClr val="3A2A30"/>
+                </a:solidFill>
+                <a:latin typeface="Calibri"/>
+              </a:defRPr>
+            </a:pPr>
+            <a:r>
+              <a:t>The florist manages catalog, vitrine, and a printable TTC invoice — not a fake 20 % TVA.</a:t>
+            </a:r>
+          </a:p>
+          <a:p>
+            <a:pPr>
+              <a:spcAft>
+                <a:spcPts val="800"/>
+              </a:spcAft>
+              <a:defRPr sz="1800">
+                <a:solidFill>
+                  <a:srgbClr val="3A2A30"/>
+                </a:solidFill>
+                <a:latin typeface="Calibri"/>
+              </a:defRPr>
+            </a:pPr>
+            <a:r>
+              <a:t>Gaps from the original Wix spec are written down. 80 tests. Secrets stay out of Git.</a:t>
+            </a:r>
+          </a:p>
+          <a:p>
+            <a:pPr>
+              <a:spcAft>
+                <a:spcPts val="800"/>
+              </a:spcAft>
+              <a:defRPr sz="1800">
+                <a:solidFill>
+                  <a:srgbClr val="3A2A30"/>
+                </a:solidFill>
+                <a:latin typeface="Calibri"/>
+              </a:defRPr>
+            </a:pPr>
+            <a:r>
+              <a:t>Next slice: operations (delivery, email, hosting), not another visual pass.</a:t>
+            </a:r>
+          </a:p>
+        </p:txBody>
+      </p:sp>
+    </p:spTree>
+  </p:cSld>
+  <p:clrMapOvr>
+    <a:masterClrMapping/>
+  </p:clrMapOvr>
+</p:sld>
+</file>
+
+<file path=ppt/slides/slide24.xml><?xml version="1.0" encoding="utf-8"?>
 <p:sld xmlns:a="http://schemas.openxmlformats.org/drawingml/2006/main" xmlns:p="http://schemas.openxmlformats.org/presentationml/2006/main" xmlns:r="http://schemas.openxmlformats.org/officeDocument/2006/relationships">
   <p:cSld>
     <p:spTree>

</xml_diff>

<commit_message>
Ship Holberton mandatory auth: email/SMS verify and customer password change.
Register issues a hashed 6-digit code (classroom demo_code, optional SMTP).
Login stays blocked until /auth/verify. Customers change their password from
the account page; forgot-password uses the same code flow. 92 tests OK.

Co-authored-by: Issercio <Issercio@users.noreply.github.com>
</commit_message>
<xml_diff>
--- a/docs/presentation/Pivoine-Lilas.pptx
+++ b/docs/presentation/Pivoine-Lilas.pptx
@@ -3276,7 +3276,7 @@
               </a:defRPr>
             </a:pPr>
             <a:r>
-              <a:t>Open (honest): no email send, no customer password-change form, reviews API unmounted, cart in localStorage, unused prices table, no public production host, JWT in localStorage (XSS residual), invoices are TTC demo docs.</a:t>
+              <a:t>Open (honest): reviews API unmounted, cart in localStorage, unused prices table, no public production host, JWT in localStorage (XSS residual), invoices are TTC demo docs. Verification/reset use classroom demo_code unless MAIL_SERVER is set.</a:t>
             </a:r>
           </a:p>
           <a:p>
@@ -3853,7 +3853,7 @@
               </a:defRPr>
             </a:pPr>
             <a:r>
-              <a:t>CNIL: 5 failed logins → 429 for 15 minutes. Still missing: customer password-change form, mail verify.</a:t>
+              <a:t>CNIL: 5 failed logins → 429 for 15 minutes. Email/SMS verify + customer password change ship (6-digit code).</a:t>
             </a:r>
           </a:p>
         </p:txBody>
@@ -4023,7 +4023,7 @@
                 </a:solidFill>
                 <a:latin typeface="Arial"/>
               </a:rPr>
-              <a:t>Testing — 86 tests OK</a:t>
+              <a:t>Testing — 92 tests OK</a:t>
             </a:r>
           </a:p>
         </p:txBody>
@@ -6557,7 +6557,7 @@
               </a:defRPr>
             </a:pPr>
             <a:r>
-              <a:t>Gaps from the original Wix spec are written down. 86 tests. Secrets stay out of Git. HTTPS and CNIL lockout ship.</a:t>
+              <a:t>Gaps from the original Wix spec are written down. 92 tests. Secrets stay out of Git. HTTPS, CNIL lockout, email/SMS verify and password change ship.</a:t>
             </a:r>
           </a:p>
           <a:p>
@@ -6573,7 +6573,7 @@
               </a:defRPr>
             </a:pPr>
             <a:r>
-              <a:t>Still not 100 % of Holberton mandatory product items: email/SMS verification and a customer password-change form.</a:t>
+              <a:t>Wix leftovers still cut: click-and-collect, geo, homepage CMS, fiscal HT/TVA.</a:t>
             </a:r>
           </a:p>
           <a:p>
@@ -6781,7 +6781,7 @@
               </a:defRPr>
             </a:pPr>
             <a:r>
-              <a:t>Evidence: github.com/Issercio/Demo-day · ./run-tests.sh (86 tests).</a:t>
+              <a:t>Evidence: github.com/Issercio/Demo-day · ./run-tests.sh (92 tests).</a:t>
             </a:r>
           </a:p>
           <a:p>
@@ -7156,7 +7156,7 @@
               </a:defRPr>
             </a:pPr>
             <a:r>
-              <a:t>Payments: test cards or Stripe API. Photos on disk. unittest + coverage (86 tests).</a:t>
+              <a:t>Payments: test cards or Stripe API. Photos on disk. unittest + coverage (92 tests).</a:t>
             </a:r>
           </a:p>
           <a:p>
@@ -7951,7 +7951,7 @@
                 <a:gridCol w="3779520"/>
                 <a:gridCol w="3779520"/>
               </a:tblGrid>
-              <a:tr h="640080">
+              <a:tr h="853440">
                 <a:tc>
                   <a:txBody>
                     <a:bodyPr/>
@@ -8025,7 +8025,7 @@
                   </a:tcPr>
                 </a:tc>
               </a:tr>
-              <a:tr h="640080">
+              <a:tr h="853440">
                 <a:tc>
                   <a:txBody>
                     <a:bodyPr/>
@@ -8040,7 +8040,7 @@
                         </a:defRPr>
                       </a:pPr>
                       <a:r>
-                        <a:t>Email verification / reset mail</a:t>
+                        <a:t>Click-and-collect slot</a:t>
                       </a:r>
                     </a:p>
                   </a:txBody>
@@ -8060,7 +8060,7 @@
                         </a:defRPr>
                       </a:pPr>
                       <a:r>
-                        <a:t>No mail provider in class</a:t>
+                        <a:t>Time-box</a:t>
                       </a:r>
                     </a:p>
                   </a:txBody>
@@ -8080,14 +8080,14 @@
                         </a:defRPr>
                       </a:pPr>
                       <a:r>
-                        <a:t>UI pages only</a:t>
+                        <a:t>Paid order, no window</a:t>
                       </a:r>
                     </a:p>
                   </a:txBody>
                   <a:tcPr/>
                 </a:tc>
               </a:tr>
-              <a:tr h="640080">
+              <a:tr h="853440">
                 <a:tc>
                   <a:txBody>
                     <a:bodyPr/>
@@ -8102,7 +8102,7 @@
                         </a:defRPr>
                       </a:pPr>
                       <a:r>
-                        <a:t>Password change by customer</a:t>
+                        <a:t>Delivery zones</a:t>
                       </a:r>
                     </a:p>
                   </a:txBody>
@@ -8126,7 +8126,7 @@
                         </a:defRPr>
                       </a:pPr>
                       <a:r>
-                        <a:t>PUT /users is admin-only</a:t>
+                        <a:t>No geo table</a:t>
                       </a:r>
                     </a:p>
                   </a:txBody>
@@ -8150,7 +8150,7 @@
                         </a:defRPr>
                       </a:pPr>
                       <a:r>
-                        <a:t>Hash exists, no form</a:t>
+                        <a:t>Not modelled</a:t>
                       </a:r>
                     </a:p>
                   </a:txBody>
@@ -8161,7 +8161,7 @@
                   </a:tcPr>
                 </a:tc>
               </a:tr>
-              <a:tr h="640080">
+              <a:tr h="853440">
                 <a:tc>
                   <a:txBody>
                     <a:bodyPr/>
@@ -8176,7 +8176,7 @@
                         </a:defRPr>
                       </a:pPr>
                       <a:r>
-                        <a:t>Click-and-collect slot</a:t>
+                        <a:t>Homepage CMS</a:t>
                       </a:r>
                     </a:p>
                   </a:txBody>
@@ -8196,7 +8196,7 @@
                         </a:defRPr>
                       </a:pPr>
                       <a:r>
-                        <a:t>Time-box</a:t>
+                        <a:t>Vitrine is the shop window</a:t>
                       </a:r>
                     </a:p>
                   </a:txBody>
@@ -8216,14 +8216,14 @@
                         </a:defRPr>
                       </a:pPr>
                       <a:r>
-                        <a:t>Paid order, no window</a:t>
+                        <a:t>accueil is a template</a:t>
                       </a:r>
                     </a:p>
                   </a:txBody>
                   <a:tcPr/>
                 </a:tc>
               </a:tr>
-              <a:tr h="640080">
+              <a:tr h="853440">
                 <a:tc>
                   <a:txBody>
                     <a:bodyPr/>
@@ -8238,7 +8238,7 @@
                         </a:defRPr>
                       </a:pPr>
                       <a:r>
-                        <a:t>Delivery zones</a:t>
+                        <a:t>HT + TVA invoice</a:t>
                       </a:r>
                     </a:p>
                   </a:txBody>
@@ -8262,7 +8262,7 @@
                         </a:defRPr>
                       </a:pPr>
                       <a:r>
-                        <a:t>No geo table</a:t>
+                        <a:t>CGV has no VAT regime</a:t>
                       </a:r>
                     </a:p>
                   </a:txBody>
@@ -8286,7 +8286,7 @@
                         </a:defRPr>
                       </a:pPr>
                       <a:r>
-                        <a:t>Not modelled</a:t>
+                        <a:t>TTC demo FAC only</a:t>
                       </a:r>
                     </a:p>
                   </a:txBody>
@@ -8297,143 +8297,7 @@
                   </a:tcPr>
                 </a:tc>
               </a:tr>
-              <a:tr h="640080">
-                <a:tc>
-                  <a:txBody>
-                    <a:bodyPr/>
-                    <a:lstStyle/>
-                    <a:p>
-                      <a:pPr>
-                        <a:defRPr sz="1200">
-                          <a:solidFill>
-                            <a:srgbClr val="3A2A30"/>
-                          </a:solidFill>
-                          <a:latin typeface="Arial"/>
-                        </a:defRPr>
-                      </a:pPr>
-                      <a:r>
-                        <a:t>Homepage CMS</a:t>
-                      </a:r>
-                    </a:p>
-                  </a:txBody>
-                  <a:tcPr/>
-                </a:tc>
-                <a:tc>
-                  <a:txBody>
-                    <a:bodyPr/>
-                    <a:lstStyle/>
-                    <a:p>
-                      <a:pPr>
-                        <a:defRPr sz="1200">
-                          <a:solidFill>
-                            <a:srgbClr val="3A2A30"/>
-                          </a:solidFill>
-                          <a:latin typeface="Arial"/>
-                        </a:defRPr>
-                      </a:pPr>
-                      <a:r>
-                        <a:t>Vitrine is the shop window</a:t>
-                      </a:r>
-                    </a:p>
-                  </a:txBody>
-                  <a:tcPr/>
-                </a:tc>
-                <a:tc>
-                  <a:txBody>
-                    <a:bodyPr/>
-                    <a:lstStyle/>
-                    <a:p>
-                      <a:pPr>
-                        <a:defRPr sz="1200">
-                          <a:solidFill>
-                            <a:srgbClr val="3A2A30"/>
-                          </a:solidFill>
-                          <a:latin typeface="Arial"/>
-                        </a:defRPr>
-                      </a:pPr>
-                      <a:r>
-                        <a:t>accueil is a template</a:t>
-                      </a:r>
-                    </a:p>
-                  </a:txBody>
-                  <a:tcPr/>
-                </a:tc>
-              </a:tr>
-              <a:tr h="640080">
-                <a:tc>
-                  <a:txBody>
-                    <a:bodyPr/>
-                    <a:lstStyle/>
-                    <a:p>
-                      <a:pPr>
-                        <a:defRPr sz="1200">
-                          <a:solidFill>
-                            <a:srgbClr val="3A2A30"/>
-                          </a:solidFill>
-                          <a:latin typeface="Arial"/>
-                        </a:defRPr>
-                      </a:pPr>
-                      <a:r>
-                        <a:t>HT + TVA invoice</a:t>
-                      </a:r>
-                    </a:p>
-                  </a:txBody>
-                  <a:tcPr>
-                    <a:solidFill>
-                      <a:srgbClr val="F8F5F2"/>
-                    </a:solidFill>
-                  </a:tcPr>
-                </a:tc>
-                <a:tc>
-                  <a:txBody>
-                    <a:bodyPr/>
-                    <a:lstStyle/>
-                    <a:p>
-                      <a:pPr>
-                        <a:defRPr sz="1200">
-                          <a:solidFill>
-                            <a:srgbClr val="3A2A30"/>
-                          </a:solidFill>
-                          <a:latin typeface="Arial"/>
-                        </a:defRPr>
-                      </a:pPr>
-                      <a:r>
-                        <a:t>CGV has no VAT regime</a:t>
-                      </a:r>
-                    </a:p>
-                  </a:txBody>
-                  <a:tcPr>
-                    <a:solidFill>
-                      <a:srgbClr val="F8F5F2"/>
-                    </a:solidFill>
-                  </a:tcPr>
-                </a:tc>
-                <a:tc>
-                  <a:txBody>
-                    <a:bodyPr/>
-                    <a:lstStyle/>
-                    <a:p>
-                      <a:pPr>
-                        <a:defRPr sz="1200">
-                          <a:solidFill>
-                            <a:srgbClr val="3A2A30"/>
-                          </a:solidFill>
-                          <a:latin typeface="Arial"/>
-                        </a:defRPr>
-                      </a:pPr>
-                      <a:r>
-                        <a:t>TTC demo FAC only</a:t>
-                      </a:r>
-                    </a:p>
-                  </a:txBody>
-                  <a:tcPr>
-                    <a:solidFill>
-                      <a:srgbClr val="F8F5F2"/>
-                    </a:solidFill>
-                  </a:tcPr>
-                </a:tc>
-              </a:tr>
-              <a:tr h="640080">
+              <a:tr h="853440">
                 <a:tc>
                   <a:txBody>
                     <a:bodyPr/>
@@ -8571,7 +8435,7 @@
               </a:defRPr>
             </a:pPr>
             <a:r>
-              <a:t>Must: auth, catalog+photos, isolated cart, server checkout, admin guard, florist invoice/prep, HTTPS, CNIL lockout.</a:t>
+              <a:t>Must: auth, catalog+photos, isolated cart, server checkout, admin guard, florist invoice/prep, HTTPS, CNIL lockout, email/SMS verify, customer password change.</a:t>
             </a:r>
           </a:p>
           <a:p>
@@ -8619,7 +8483,7 @@
               </a:defRPr>
             </a:pPr>
             <a:r>
-              <a:t>Won’t: native app, chat, AI, 2FA, OAuth, email verify, customer password form, geo, fiscal TVA.</a:t>
+              <a:t>Won’t: native app, chat, AI, 2FA, OAuth, geo, fiscal TVA.</a:t>
             </a:r>
           </a:p>
           <a:p>

</xml_diff>

<commit_message>
Document a 50/50 split: Dimitri backend, Mattieu frontend and database.
The specification (and the team slide) now state Dimitri owns the entire
Flask API and Mattieu owns the entire storefront plus the data model.

Co-authored-by: Issercio <Issercio@users.noreply.github.com>
</commit_message>
<xml_diff>
--- a/docs/presentation/Pivoine-Lilas.pptx
+++ b/docs/presentation/Pivoine-Lilas.pptx
@@ -4948,7 +4948,7 @@
                         </a:defRPr>
                       </a:pPr>
                       <a:r>
-                        <a:t>Backend lead</a:t>
+                        <a:t>Backend 50 %</a:t>
                       </a:r>
                     </a:p>
                   </a:txBody>
@@ -4968,7 +4968,7 @@
                         </a:defRPr>
                       </a:pPr>
                       <a:r>
-                        <a:t>API, SQLAlchemy, JWT, checkout, tests, HTTPS, lockout</a:t>
+                        <a:t>All API, JWT, checkout, tests, HTTPS, lockout</a:t>
                       </a:r>
                     </a:p>
                   </a:txBody>
@@ -5014,7 +5014,7 @@
                         </a:defRPr>
                       </a:pPr>
                       <a:r>
-                        <a:t>Frontend &amp; Demo Day</a:t>
+                        <a:t>Frontend + database 50 %</a:t>
                       </a:r>
                     </a:p>
                   </a:txBody>
@@ -5038,7 +5038,7 @@
                         </a:defRPr>
                       </a:pPr>
                       <a:r>
-                        <a:t>Jinja/CSS/JS, stories, deck, live demo</a:t>
+                        <a:t>All Jinja/CSS/JS, models, schema, seed, deck</a:t>
                       </a:r>
                     </a:p>
                   </a:txBody>
@@ -6765,7 +6765,7 @@
               </a:defRPr>
             </a:pPr>
             <a:r>
-              <a:t>Decisions: Mattieu on UI copy; Dimitri on money/auth. Cuts (email, geo, HT/TVA) are written as missing stories — never hidden.</a:t>
+              <a:t>Split 50/50: Dimitri = entire backend. Mattieu = entire frontend and entire database.</a:t>
             </a:r>
           </a:p>
           <a:p>

</xml_diff>

<commit_message>
Make the Word spec import into a blank Google Doc.
Drop table shading and Office extras (customXml, Far-East fonts) so
File → Open → Upload from an empty Google Doc keeps editable text.

Co-authored-by: Issercio <Issercio@users.noreply.github.com>
</commit_message>
<xml_diff>
--- a/docs/presentation/Pivoine-Lilas.pptx
+++ b/docs/presentation/Pivoine-Lilas.pptx
@@ -7124,7 +7124,7 @@
               </a:defRPr>
             </a:pPr>
             <a:r>
-              <a:t>Frontend: Jinja2 + vanilla JS, custom CSS (florist pink), localStorage cart per account.</a:t>
+              <a:t>Frontend: Jinja2 + vanilla JS, custom CSS (florist pink), localStorage cart per account (Mattieu, 50 %).</a:t>
             </a:r>
           </a:p>
           <a:p>
@@ -7140,7 +7140,23 @@
               </a:defRPr>
             </a:pPr>
             <a:r>
-              <a:t>Backend: Flask 3 + RESTX Swagger, SQLAlchemy 2 Numeric money, JWT HS256, roles from DB.</a:t>
+              <a:t>Database: SQLAlchemy models, SQLite/PostgreSQL, seed, vitrine tables (Mattieu, same 50 %).</a:t>
+            </a:r>
+          </a:p>
+          <a:p>
+            <a:pPr>
+              <a:spcAft>
+                <a:spcPts val="800"/>
+              </a:spcAft>
+              <a:defRPr sz="1700">
+                <a:solidFill>
+                  <a:srgbClr val="3A2A30"/>
+                </a:solidFill>
+                <a:latin typeface="Arial"/>
+              </a:defRPr>
+            </a:pPr>
+            <a:r>
+              <a:t>Backend: Flask 3 + RESTX Swagger, JWT HS256, Decimal checkout, tests, HTTPS, lockout (Dimitri, 50 %).</a:t>
             </a:r>
           </a:p>
           <a:p>

</xml_diff>